<commit_message>
updated review 1 ppt
</commit_message>
<xml_diff>
--- a/CSE7101-Capstone Project-Review1- CBD_7.pptx
+++ b/CSE7101-Capstone Project-Review1- CBD_7.pptx
@@ -254,7 +254,7 @@
   </p:defaultTextStyle>
   <p:extLst>
     <p:ext uri="{EFAFB233-063F-42B5-8137-9DF3F51BA10A}">
-      <p15:sldGuideLst xmlns:p15="http://schemas.microsoft.com/office/powerpoint/2012/main"/>
+      <p15:sldGuideLst xmlns:p15="http://schemas.microsoft.com/office/powerpoint/2012/main" xmlns=""/>
     </p:ext>
   </p:extLst>
 </p:presentation>
@@ -12386,14 +12386,14 @@
                 <a:gridCol w="2085000">
                   <a:extLst>
                     <a:ext uri="{9D8B030D-6E8A-4147-A177-3AD203B41FA5}">
-                      <a16:colId xmlns:a16="http://schemas.microsoft.com/office/drawing/2014/main" val="20000"/>
+                      <a16:colId xmlns:a16="http://schemas.microsoft.com/office/drawing/2014/main" xmlns="" val="20000"/>
                     </a:ext>
                   </a:extLst>
                 </a:gridCol>
                 <a:gridCol w="3333675">
                   <a:extLst>
                     <a:ext uri="{9D8B030D-6E8A-4147-A177-3AD203B41FA5}">
-                      <a16:colId xmlns:a16="http://schemas.microsoft.com/office/drawing/2014/main" val="20001"/>
+                      <a16:colId xmlns:a16="http://schemas.microsoft.com/office/drawing/2014/main" xmlns="" val="20001"/>
                     </a:ext>
                   </a:extLst>
                 </a:gridCol>
@@ -12553,7 +12553,7 @@
                 </a:tc>
                 <a:extLst>
                   <a:ext uri="{0D108BD9-81ED-4DB2-BD59-A6C34878D82A}">
-                    <a16:rowId xmlns:a16="http://schemas.microsoft.com/office/drawing/2014/main" val="10000"/>
+                    <a16:rowId xmlns:a16="http://schemas.microsoft.com/office/drawing/2014/main" xmlns="" val="10000"/>
                   </a:ext>
                 </a:extLst>
               </a:tr>
@@ -12696,7 +12696,7 @@
                 </a:tc>
                 <a:extLst>
                   <a:ext uri="{0D108BD9-81ED-4DB2-BD59-A6C34878D82A}">
-                    <a16:rowId xmlns:a16="http://schemas.microsoft.com/office/drawing/2014/main" val="10001"/>
+                    <a16:rowId xmlns:a16="http://schemas.microsoft.com/office/drawing/2014/main" xmlns="" val="10001"/>
                   </a:ext>
                 </a:extLst>
               </a:tr>
@@ -12839,7 +12839,7 @@
                 </a:tc>
                 <a:extLst>
                   <a:ext uri="{0D108BD9-81ED-4DB2-BD59-A6C34878D82A}">
-                    <a16:rowId xmlns:a16="http://schemas.microsoft.com/office/drawing/2014/main" val="10002"/>
+                    <a16:rowId xmlns:a16="http://schemas.microsoft.com/office/drawing/2014/main" xmlns="" val="10002"/>
                   </a:ext>
                 </a:extLst>
               </a:tr>
@@ -12982,7 +12982,7 @@
                 </a:tc>
                 <a:extLst>
                   <a:ext uri="{0D108BD9-81ED-4DB2-BD59-A6C34878D82A}">
-                    <a16:rowId xmlns:a16="http://schemas.microsoft.com/office/drawing/2014/main" val="10003"/>
+                    <a16:rowId xmlns:a16="http://schemas.microsoft.com/office/drawing/2014/main" xmlns="" val="10003"/>
                   </a:ext>
                 </a:extLst>
               </a:tr>
@@ -13117,7 +13117,7 @@
                 </a:tc>
                 <a:extLst>
                   <a:ext uri="{0D108BD9-81ED-4DB2-BD59-A6C34878D82A}">
-                    <a16:rowId xmlns:a16="http://schemas.microsoft.com/office/drawing/2014/main" val="10004"/>
+                    <a16:rowId xmlns:a16="http://schemas.microsoft.com/office/drawing/2014/main" xmlns="" val="10004"/>
                   </a:ext>
                 </a:extLst>
               </a:tr>
@@ -13252,7 +13252,7 @@
                 </a:tc>
                 <a:extLst>
                   <a:ext uri="{0D108BD9-81ED-4DB2-BD59-A6C34878D82A}">
-                    <a16:rowId xmlns:a16="http://schemas.microsoft.com/office/drawing/2014/main" val="10005"/>
+                    <a16:rowId xmlns:a16="http://schemas.microsoft.com/office/drawing/2014/main" xmlns="" val="10005"/>
                   </a:ext>
                 </a:extLst>
               </a:tr>
@@ -13943,7 +13943,7 @@
           <p:cNvPr id="5" name="Picture 4">
             <a:extLst>
               <a:ext uri="{FF2B5EF4-FFF2-40B4-BE49-F238E27FC236}">
-                <a16:creationId xmlns:a16="http://schemas.microsoft.com/office/drawing/2014/main" id="{C63A00FF-89F0-DC87-D900-930227B33E5D}"/>
+                <a16:creationId xmlns:a16="http://schemas.microsoft.com/office/drawing/2014/main" xmlns="" id="{C63A00FF-89F0-DC87-D900-930227B33E5D}"/>
               </a:ext>
             </a:extLst>
           </p:cNvPr>
@@ -16363,35 +16363,7 @@
                 <a:latin typeface="Cambria" panose="02040503050406030204" pitchFamily="18" charset="0"/>
                 <a:ea typeface="Cambria" panose="02040503050406030204" pitchFamily="18" charset="0"/>
               </a:rPr>
-              <a:t>Graphical representation (charts, </a:t>
-            </a:r>
-            <a:r>
-              <a:rPr kumimoji="0" lang="en-US" altLang="en-US" sz="2000" b="0" i="0" u="none" strike="noStrike" cap="none" normalizeH="0" baseline="0" dirty="0" smtClean="0">
-                <a:ln>
-                  <a:noFill/>
-                </a:ln>
-                <a:solidFill>
-                  <a:schemeClr val="tx1"/>
-                </a:solidFill>
-                <a:effectLst/>
-                <a:latin typeface="Cambria" panose="02040503050406030204" pitchFamily="18" charset="0"/>
-                <a:ea typeface="Cambria" panose="02040503050406030204" pitchFamily="18" charset="0"/>
-              </a:rPr>
-              <a:t>heat maps, </a:t>
-            </a:r>
-            <a:r>
-              <a:rPr kumimoji="0" lang="en-US" altLang="en-US" sz="2000" b="0" i="0" u="none" strike="noStrike" cap="none" normalizeH="0" baseline="0" dirty="0" smtClean="0">
-                <a:ln>
-                  <a:noFill/>
-                </a:ln>
-                <a:solidFill>
-                  <a:schemeClr val="tx1"/>
-                </a:solidFill>
-                <a:effectLst/>
-                <a:latin typeface="Cambria" panose="02040503050406030204" pitchFamily="18" charset="0"/>
-                <a:ea typeface="Cambria" panose="02040503050406030204" pitchFamily="18" charset="0"/>
-              </a:rPr>
-              <a:t>reports) for easy decision-making.</a:t>
+              <a:t>Graphical representation (charts, heat maps, reports) for easy decision-making.</a:t>
             </a:r>
           </a:p>
           <a:p>
@@ -17321,14 +17293,21 @@
                 <a:latin typeface="Cambria" panose="02040503050406030204" pitchFamily="18" charset="0"/>
                 <a:ea typeface="Cambria" panose="02040503050406030204" pitchFamily="18" charset="0"/>
               </a:rPr>
-              <a:t>, CSS3, </a:t>
+              <a:t>, CSS3</a:t>
             </a:r>
             <a:r>
-              <a:rPr lang="en-GB" sz="2200" dirty="0" smtClean="0">
+              <a:rPr lang="en-GB" sz="2200">
                 <a:latin typeface="Cambria" panose="02040503050406030204" pitchFamily="18" charset="0"/>
                 <a:ea typeface="Cambria" panose="02040503050406030204" pitchFamily="18" charset="0"/>
               </a:rPr>
-              <a:t>JavaScript, Bootstrap, Chart.js</a:t>
+              <a:t>, </a:t>
+            </a:r>
+            <a:r>
+              <a:rPr lang="en-GB" sz="2200" smtClean="0">
+                <a:latin typeface="Cambria" panose="02040503050406030204" pitchFamily="18" charset="0"/>
+                <a:ea typeface="Cambria" panose="02040503050406030204" pitchFamily="18" charset="0"/>
+              </a:rPr>
+              <a:t>JavaScript</a:t>
             </a:r>
           </a:p>
           <a:p>
@@ -17337,7 +17316,7 @@
               <a:buAutoNum type="arabicPeriod"/>
             </a:pPr>
             <a:r>
-              <a:rPr lang="en-GB" sz="2200" dirty="0" smtClean="0">
+              <a:rPr lang="en-GB" sz="2200" smtClean="0">
                 <a:latin typeface="Cambria" panose="02040503050406030204" pitchFamily="18" charset="0"/>
                 <a:ea typeface="Cambria" panose="02040503050406030204" pitchFamily="18" charset="0"/>
               </a:rPr>

</xml_diff>